<commit_message>
Assets: Dropbox photos sorted into 5 categories; OTT Creator House 14-slide deck and overview copy
Co-Authored-By: Claude Opus 5.5 <noreply@anthropic.com>
Claude-Session: https://claude.ai/code/session_01NC15hwWk5Sc4RQZebEGKHu
</commit_message>
<xml_diff>
--- a/media/deck/OTT-Creator-House-FY27.pptx
+++ b/media/deck/OTT-Creator-House-FY27.pptx
@@ -11,6 +11,14 @@
     <p:sldId id="259" r:id="rId10"/>
     <p:sldId id="260" r:id="rId11"/>
     <p:sldId id="261" r:id="rId12"/>
+    <p:sldId id="262" r:id="rId13"/>
+    <p:sldId id="263" r:id="rId14"/>
+    <p:sldId id="264" r:id="rId15"/>
+    <p:sldId id="265" r:id="rId16"/>
+    <p:sldId id="266" r:id="rId17"/>
+    <p:sldId id="267" r:id="rId18"/>
+    <p:sldId id="268" r:id="rId19"/>
+    <p:sldId id="269" r:id="rId20"/>
   </p:sldIdLst>
   <p:sldSz cx="12192000" cy="6858000" type="screen4x3"/>
   <p:notesSz cx="6858000" cy="9144000"/>
@@ -3125,6 +3133,216 @@
 </p:sld>
 </file>
 
+<file path=ppt/slides/slide10.xml><?xml version="1.0" encoding="utf-8"?>
+<p:sld xmlns:a="http://schemas.openxmlformats.org/drawingml/2006/main" xmlns:p="http://schemas.openxmlformats.org/presentationml/2006/main" xmlns:r="http://schemas.openxmlformats.org/officeDocument/2006/relationships">
+  <p:cSld>
+    <p:spTree>
+      <p:nvGrpSpPr>
+        <p:cNvPr id="1" name=""/>
+        <p:cNvGrpSpPr/>
+        <p:nvPr/>
+      </p:nvGrpSpPr>
+      <p:grpSpPr/>
+      <p:pic>
+        <p:nvPicPr>
+          <p:cNvPr id="2" name="Picture 1" descr="slide-10.jpg"/>
+          <p:cNvPicPr>
+            <a:picLocks noChangeAspect="1"/>
+          </p:cNvPicPr>
+          <p:nvPr/>
+        </p:nvPicPr>
+        <p:blipFill>
+          <a:blip r:embed="rId2"/>
+          <a:stretch>
+            <a:fillRect/>
+          </a:stretch>
+        </p:blipFill>
+        <p:spPr>
+          <a:xfrm>
+            <a:off x="0" y="0"/>
+            <a:ext cx="12192000" cy="6858000"/>
+          </a:xfrm>
+          <a:prstGeom prst="rect">
+            <a:avLst/>
+          </a:prstGeom>
+        </p:spPr>
+      </p:pic>
+    </p:spTree>
+  </p:cSld>
+  <p:clrMapOvr>
+    <a:masterClrMapping/>
+  </p:clrMapOvr>
+</p:sld>
+</file>
+
+<file path=ppt/slides/slide11.xml><?xml version="1.0" encoding="utf-8"?>
+<p:sld xmlns:a="http://schemas.openxmlformats.org/drawingml/2006/main" xmlns:p="http://schemas.openxmlformats.org/presentationml/2006/main" xmlns:r="http://schemas.openxmlformats.org/officeDocument/2006/relationships">
+  <p:cSld>
+    <p:spTree>
+      <p:nvGrpSpPr>
+        <p:cNvPr id="1" name=""/>
+        <p:cNvGrpSpPr/>
+        <p:nvPr/>
+      </p:nvGrpSpPr>
+      <p:grpSpPr/>
+      <p:pic>
+        <p:nvPicPr>
+          <p:cNvPr id="2" name="Picture 1" descr="slide-11.jpg"/>
+          <p:cNvPicPr>
+            <a:picLocks noChangeAspect="1"/>
+          </p:cNvPicPr>
+          <p:nvPr/>
+        </p:nvPicPr>
+        <p:blipFill>
+          <a:blip r:embed="rId2"/>
+          <a:stretch>
+            <a:fillRect/>
+          </a:stretch>
+        </p:blipFill>
+        <p:spPr>
+          <a:xfrm>
+            <a:off x="0" y="0"/>
+            <a:ext cx="12192000" cy="6858000"/>
+          </a:xfrm>
+          <a:prstGeom prst="rect">
+            <a:avLst/>
+          </a:prstGeom>
+        </p:spPr>
+      </p:pic>
+    </p:spTree>
+  </p:cSld>
+  <p:clrMapOvr>
+    <a:masterClrMapping/>
+  </p:clrMapOvr>
+</p:sld>
+</file>
+
+<file path=ppt/slides/slide12.xml><?xml version="1.0" encoding="utf-8"?>
+<p:sld xmlns:a="http://schemas.openxmlformats.org/drawingml/2006/main" xmlns:p="http://schemas.openxmlformats.org/presentationml/2006/main" xmlns:r="http://schemas.openxmlformats.org/officeDocument/2006/relationships">
+  <p:cSld>
+    <p:spTree>
+      <p:nvGrpSpPr>
+        <p:cNvPr id="1" name=""/>
+        <p:cNvGrpSpPr/>
+        <p:nvPr/>
+      </p:nvGrpSpPr>
+      <p:grpSpPr/>
+      <p:pic>
+        <p:nvPicPr>
+          <p:cNvPr id="2" name="Picture 1" descr="slide-12.jpg"/>
+          <p:cNvPicPr>
+            <a:picLocks noChangeAspect="1"/>
+          </p:cNvPicPr>
+          <p:nvPr/>
+        </p:nvPicPr>
+        <p:blipFill>
+          <a:blip r:embed="rId2"/>
+          <a:stretch>
+            <a:fillRect/>
+          </a:stretch>
+        </p:blipFill>
+        <p:spPr>
+          <a:xfrm>
+            <a:off x="0" y="0"/>
+            <a:ext cx="12192000" cy="6858000"/>
+          </a:xfrm>
+          <a:prstGeom prst="rect">
+            <a:avLst/>
+          </a:prstGeom>
+        </p:spPr>
+      </p:pic>
+    </p:spTree>
+  </p:cSld>
+  <p:clrMapOvr>
+    <a:masterClrMapping/>
+  </p:clrMapOvr>
+</p:sld>
+</file>
+
+<file path=ppt/slides/slide13.xml><?xml version="1.0" encoding="utf-8"?>
+<p:sld xmlns:a="http://schemas.openxmlformats.org/drawingml/2006/main" xmlns:p="http://schemas.openxmlformats.org/presentationml/2006/main" xmlns:r="http://schemas.openxmlformats.org/officeDocument/2006/relationships">
+  <p:cSld>
+    <p:spTree>
+      <p:nvGrpSpPr>
+        <p:cNvPr id="1" name=""/>
+        <p:cNvGrpSpPr/>
+        <p:nvPr/>
+      </p:nvGrpSpPr>
+      <p:grpSpPr/>
+      <p:pic>
+        <p:nvPicPr>
+          <p:cNvPr id="2" name="Picture 1" descr="slide-13.jpg"/>
+          <p:cNvPicPr>
+            <a:picLocks noChangeAspect="1"/>
+          </p:cNvPicPr>
+          <p:nvPr/>
+        </p:nvPicPr>
+        <p:blipFill>
+          <a:blip r:embed="rId2"/>
+          <a:stretch>
+            <a:fillRect/>
+          </a:stretch>
+        </p:blipFill>
+        <p:spPr>
+          <a:xfrm>
+            <a:off x="0" y="0"/>
+            <a:ext cx="12192000" cy="6858000"/>
+          </a:xfrm>
+          <a:prstGeom prst="rect">
+            <a:avLst/>
+          </a:prstGeom>
+        </p:spPr>
+      </p:pic>
+    </p:spTree>
+  </p:cSld>
+  <p:clrMapOvr>
+    <a:masterClrMapping/>
+  </p:clrMapOvr>
+</p:sld>
+</file>
+
+<file path=ppt/slides/slide14.xml><?xml version="1.0" encoding="utf-8"?>
+<p:sld xmlns:a="http://schemas.openxmlformats.org/drawingml/2006/main" xmlns:p="http://schemas.openxmlformats.org/presentationml/2006/main" xmlns:r="http://schemas.openxmlformats.org/officeDocument/2006/relationships">
+  <p:cSld>
+    <p:spTree>
+      <p:nvGrpSpPr>
+        <p:cNvPr id="1" name=""/>
+        <p:cNvGrpSpPr/>
+        <p:nvPr/>
+      </p:nvGrpSpPr>
+      <p:grpSpPr/>
+      <p:pic>
+        <p:nvPicPr>
+          <p:cNvPr id="2" name="Picture 1" descr="slide-14.jpg"/>
+          <p:cNvPicPr>
+            <a:picLocks noChangeAspect="1"/>
+          </p:cNvPicPr>
+          <p:nvPr/>
+        </p:nvPicPr>
+        <p:blipFill>
+          <a:blip r:embed="rId2"/>
+          <a:stretch>
+            <a:fillRect/>
+          </a:stretch>
+        </p:blipFill>
+        <p:spPr>
+          <a:xfrm>
+            <a:off x="0" y="0"/>
+            <a:ext cx="12192000" cy="6858000"/>
+          </a:xfrm>
+          <a:prstGeom prst="rect">
+            <a:avLst/>
+          </a:prstGeom>
+        </p:spPr>
+      </p:pic>
+    </p:spTree>
+  </p:cSld>
+  <p:clrMapOvr>
+    <a:masterClrMapping/>
+  </p:clrMapOvr>
+</p:sld>
+</file>
+
 <file path=ppt/slides/slide2.xml><?xml version="1.0" encoding="utf-8"?>
 <p:sld xmlns:a="http://schemas.openxmlformats.org/drawingml/2006/main" xmlns:p="http://schemas.openxmlformats.org/presentationml/2006/main" xmlns:r="http://schemas.openxmlformats.org/officeDocument/2006/relationships">
   <p:cSld>
@@ -3306,6 +3524,132 @@
       <p:pic>
         <p:nvPicPr>
           <p:cNvPr id="2" name="Picture 1" descr="slide-6.jpg"/>
+          <p:cNvPicPr>
+            <a:picLocks noChangeAspect="1"/>
+          </p:cNvPicPr>
+          <p:nvPr/>
+        </p:nvPicPr>
+        <p:blipFill>
+          <a:blip r:embed="rId2"/>
+          <a:stretch>
+            <a:fillRect/>
+          </a:stretch>
+        </p:blipFill>
+        <p:spPr>
+          <a:xfrm>
+            <a:off x="0" y="0"/>
+            <a:ext cx="12192000" cy="6858000"/>
+          </a:xfrm>
+          <a:prstGeom prst="rect">
+            <a:avLst/>
+          </a:prstGeom>
+        </p:spPr>
+      </p:pic>
+    </p:spTree>
+  </p:cSld>
+  <p:clrMapOvr>
+    <a:masterClrMapping/>
+  </p:clrMapOvr>
+</p:sld>
+</file>
+
+<file path=ppt/slides/slide7.xml><?xml version="1.0" encoding="utf-8"?>
+<p:sld xmlns:a="http://schemas.openxmlformats.org/drawingml/2006/main" xmlns:p="http://schemas.openxmlformats.org/presentationml/2006/main" xmlns:r="http://schemas.openxmlformats.org/officeDocument/2006/relationships">
+  <p:cSld>
+    <p:spTree>
+      <p:nvGrpSpPr>
+        <p:cNvPr id="1" name=""/>
+        <p:cNvGrpSpPr/>
+        <p:nvPr/>
+      </p:nvGrpSpPr>
+      <p:grpSpPr/>
+      <p:pic>
+        <p:nvPicPr>
+          <p:cNvPr id="2" name="Picture 1" descr="slide-7.jpg"/>
+          <p:cNvPicPr>
+            <a:picLocks noChangeAspect="1"/>
+          </p:cNvPicPr>
+          <p:nvPr/>
+        </p:nvPicPr>
+        <p:blipFill>
+          <a:blip r:embed="rId2"/>
+          <a:stretch>
+            <a:fillRect/>
+          </a:stretch>
+        </p:blipFill>
+        <p:spPr>
+          <a:xfrm>
+            <a:off x="0" y="0"/>
+            <a:ext cx="12192000" cy="6858000"/>
+          </a:xfrm>
+          <a:prstGeom prst="rect">
+            <a:avLst/>
+          </a:prstGeom>
+        </p:spPr>
+      </p:pic>
+    </p:spTree>
+  </p:cSld>
+  <p:clrMapOvr>
+    <a:masterClrMapping/>
+  </p:clrMapOvr>
+</p:sld>
+</file>
+
+<file path=ppt/slides/slide8.xml><?xml version="1.0" encoding="utf-8"?>
+<p:sld xmlns:a="http://schemas.openxmlformats.org/drawingml/2006/main" xmlns:p="http://schemas.openxmlformats.org/presentationml/2006/main" xmlns:r="http://schemas.openxmlformats.org/officeDocument/2006/relationships">
+  <p:cSld>
+    <p:spTree>
+      <p:nvGrpSpPr>
+        <p:cNvPr id="1" name=""/>
+        <p:cNvGrpSpPr/>
+        <p:nvPr/>
+      </p:nvGrpSpPr>
+      <p:grpSpPr/>
+      <p:pic>
+        <p:nvPicPr>
+          <p:cNvPr id="2" name="Picture 1" descr="slide-8.jpg"/>
+          <p:cNvPicPr>
+            <a:picLocks noChangeAspect="1"/>
+          </p:cNvPicPr>
+          <p:nvPr/>
+        </p:nvPicPr>
+        <p:blipFill>
+          <a:blip r:embed="rId2"/>
+          <a:stretch>
+            <a:fillRect/>
+          </a:stretch>
+        </p:blipFill>
+        <p:spPr>
+          <a:xfrm>
+            <a:off x="0" y="0"/>
+            <a:ext cx="12192000" cy="6858000"/>
+          </a:xfrm>
+          <a:prstGeom prst="rect">
+            <a:avLst/>
+          </a:prstGeom>
+        </p:spPr>
+      </p:pic>
+    </p:spTree>
+  </p:cSld>
+  <p:clrMapOvr>
+    <a:masterClrMapping/>
+  </p:clrMapOvr>
+</p:sld>
+</file>
+
+<file path=ppt/slides/slide9.xml><?xml version="1.0" encoding="utf-8"?>
+<p:sld xmlns:a="http://schemas.openxmlformats.org/drawingml/2006/main" xmlns:p="http://schemas.openxmlformats.org/presentationml/2006/main" xmlns:r="http://schemas.openxmlformats.org/officeDocument/2006/relationships">
+  <p:cSld>
+    <p:spTree>
+      <p:nvGrpSpPr>
+        <p:cNvPr id="1" name=""/>
+        <p:cNvGrpSpPr/>
+        <p:nvPr/>
+      </p:nvGrpSpPr>
+      <p:grpSpPr/>
+      <p:pic>
+        <p:nvPicPr>
+          <p:cNvPr id="2" name="Picture 1" descr="slide-9.jpg"/>
           <p:cNvPicPr>
             <a:picLocks noChangeAspect="1"/>
           </p:cNvPicPr>

</xml_diff>

<commit_message>
Deck: add 'You're at step 02' and 'The real work' loop slides
Co-Authored-By: Claude Opus 5.5 <noreply@anthropic.com>
Claude-Session: https://claude.ai/code/session_01NC15hwWk5Sc4RQZebEGKHu
</commit_message>
<xml_diff>
--- a/media/deck/OTT-Creator-House-FY27.pptx
+++ b/media/deck/OTT-Creator-House-FY27.pptx
@@ -19,6 +19,8 @@
     <p:sldId id="267" r:id="rId18"/>
     <p:sldId id="268" r:id="rId19"/>
     <p:sldId id="269" r:id="rId20"/>
+    <p:sldId id="270" r:id="rId21"/>
+    <p:sldId id="271" r:id="rId22"/>
   </p:sldIdLst>
   <p:sldSz cx="12192000" cy="6858000" type="screen4x3"/>
   <p:notesSz cx="6858000" cy="9144000"/>
@@ -3314,6 +3316,90 @@
       <p:pic>
         <p:nvPicPr>
           <p:cNvPr id="2" name="Picture 1" descr="slide-14.jpg"/>
+          <p:cNvPicPr>
+            <a:picLocks noChangeAspect="1"/>
+          </p:cNvPicPr>
+          <p:nvPr/>
+        </p:nvPicPr>
+        <p:blipFill>
+          <a:blip r:embed="rId2"/>
+          <a:stretch>
+            <a:fillRect/>
+          </a:stretch>
+        </p:blipFill>
+        <p:spPr>
+          <a:xfrm>
+            <a:off x="0" y="0"/>
+            <a:ext cx="12192000" cy="6858000"/>
+          </a:xfrm>
+          <a:prstGeom prst="rect">
+            <a:avLst/>
+          </a:prstGeom>
+        </p:spPr>
+      </p:pic>
+    </p:spTree>
+  </p:cSld>
+  <p:clrMapOvr>
+    <a:masterClrMapping/>
+  </p:clrMapOvr>
+</p:sld>
+</file>
+
+<file path=ppt/slides/slide15.xml><?xml version="1.0" encoding="utf-8"?>
+<p:sld xmlns:a="http://schemas.openxmlformats.org/drawingml/2006/main" xmlns:p="http://schemas.openxmlformats.org/presentationml/2006/main" xmlns:r="http://schemas.openxmlformats.org/officeDocument/2006/relationships">
+  <p:cSld>
+    <p:spTree>
+      <p:nvGrpSpPr>
+        <p:cNvPr id="1" name=""/>
+        <p:cNvGrpSpPr/>
+        <p:nvPr/>
+      </p:nvGrpSpPr>
+      <p:grpSpPr/>
+      <p:pic>
+        <p:nvPicPr>
+          <p:cNvPr id="2" name="Picture 1" descr="slide-15.jpg"/>
+          <p:cNvPicPr>
+            <a:picLocks noChangeAspect="1"/>
+          </p:cNvPicPr>
+          <p:nvPr/>
+        </p:nvPicPr>
+        <p:blipFill>
+          <a:blip r:embed="rId2"/>
+          <a:stretch>
+            <a:fillRect/>
+          </a:stretch>
+        </p:blipFill>
+        <p:spPr>
+          <a:xfrm>
+            <a:off x="0" y="0"/>
+            <a:ext cx="12192000" cy="6858000"/>
+          </a:xfrm>
+          <a:prstGeom prst="rect">
+            <a:avLst/>
+          </a:prstGeom>
+        </p:spPr>
+      </p:pic>
+    </p:spTree>
+  </p:cSld>
+  <p:clrMapOvr>
+    <a:masterClrMapping/>
+  </p:clrMapOvr>
+</p:sld>
+</file>
+
+<file path=ppt/slides/slide16.xml><?xml version="1.0" encoding="utf-8"?>
+<p:sld xmlns:a="http://schemas.openxmlformats.org/drawingml/2006/main" xmlns:p="http://schemas.openxmlformats.org/presentationml/2006/main" xmlns:r="http://schemas.openxmlformats.org/officeDocument/2006/relationships">
+  <p:cSld>
+    <p:spTree>
+      <p:nvGrpSpPr>
+        <p:cNvPr id="1" name=""/>
+        <p:cNvGrpSpPr/>
+        <p:nvPr/>
+      </p:nvGrpSpPr>
+      <p:grpSpPr/>
+      <p:pic>
+        <p:nvPicPr>
+          <p:cNvPr id="2" name="Picture 1" descr="slide-16.jpg"/>
           <p:cNvPicPr>
             <a:picLocks noChangeAspect="1"/>
           </p:cNvPicPr>

</xml_diff>